<commit_message>
fix(diagrams): component diagram still showed 7 strategies
The Mermaid copy embedded in index.html was never updated when the two hybrid
strategies landed: the Strategy layer read "7x CodaStrategy" / "7x SwiftStrategy"
and the Parser layer listed seven wrappers. It now reads 9x/9x with
SpringBatch+FixedFormat4J and SpringBatch+FixedLength wired in, matching
docs/diagrams/component-diagram.mmd.

Diagram labels also spell the approach out instead of abbreviating it:
SB+FF4J / SpringBatch+FF4J are now SpringBatch+FixedFormat4J in the Marp deck,
the PPTX generator and the frontend system-architecture diagram. The deck's
strategy fan-out lists the nine approaches by name rather than as cryptic
two-letter codes.

Verified in a browser with a cache-busting load: 7 SVGs render, zero Mermaid
errors, "9x CodaStrategy"/"9x SwiftStrategy" present, no "7x" and no
"SpringBatch+FF4J" anywhere. Also gitignores .playwright-mcp session snapshots.
</commit_message>
<xml_diff>
--- a/docs/slides/banking-parser-platform.pptx
+++ b/docs/slides/banking-parser-platform.pptx
@@ -16330,7 +16330,7 @@
                 </a:solidFill>
                 <a:latin typeface="Courier New"/>
               </a:rPr>
-              <a:t>                     /    |    |    |    |    |    |    |    \</a:t>
+              <a:t>                                      |</a:t>
             </a:r>
           </a:p>
           <a:p>
@@ -16341,7 +16341,7 @@
                 </a:solidFill>
                 <a:latin typeface="Courier New"/>
               </a:rPr>
-              <a:t>                BeanIO  ff4j  VL  Bindy CamelBIO Vel  SB  SB+FF4J  SB+VL</a:t>
+              <a:t>        BeanIO, FixedFormat4J, FixedLength, Bindy, CamelBeanIO, Velocity,</a:t>
             </a:r>
           </a:p>
           <a:p>
@@ -16352,7 +16352,18 @@
                 </a:solidFill>
                 <a:latin typeface="Courier New"/>
               </a:rPr>
-              <a:t>                              |</a:t>
+              <a:t>        SpringBatch, SpringBatch+FixedFormat4J, SpringBatch+FixedLength</a:t>
+            </a:r>
+          </a:p>
+          <a:p>
+            <a:r>
+              <a:rPr sz="1300">
+                <a:solidFill>
+                  <a:srgbClr val="D4D4D4"/>
+                </a:solidFill>
+                <a:latin typeface="Courier New"/>
+              </a:rPr>
+              <a:t>                                      |</a:t>
             </a:r>
           </a:p>
           <a:p>

</xml_diff>